<commit_message>
Update evaluation slide with goal answer, evidence checklist, intentional limits.
</commit_message>
<xml_diff>
--- a/docs/presentation/MinduelLite-Oral-Project-Report.pptx
+++ b/docs/presentation/MinduelLite-Oral-Project-Report.pptx
@@ -5327,7 +5327,7 @@
                 <a:ea typeface="Calibri" pitchFamily="34" charset="-122"/>
                 <a:cs typeface="Calibri" pitchFamily="34" charset="-120"/>
               </a:rPr>
-              <a:t>6. Evaluation — goal &amp; limitations</a:t>
+              <a:t>6. Evaluation — was the goal achieved?</a:t>
             </a:r>
             <a:endParaRPr lang="en-US" sz="2400" dirty="0"/>
           </a:p>
@@ -5360,41 +5360,14 @@
       </p:sp>
       <p:sp>
         <p:nvSpPr>
-          <p:cNvPr id="4" name="Shape 2"/>
-          <p:cNvSpPr/>
-          <p:nvPr/>
-        </p:nvSpPr>
-        <p:spPr>
-          <a:xfrm>
-            <a:off x="457200" y="1005840"/>
-            <a:ext cx="4023360" cy="3200400"/>
-          </a:xfrm>
-          <a:prstGeom prst="roundRect">
-            <a:avLst>
-              <a:gd name="adj" fmla="val 2286"/>
-            </a:avLst>
-          </a:prstGeom>
-          <a:solidFill>
-            <a:srgbClr val="1A2332"/>
-          </a:solidFill>
-          <a:ln w="12700">
-            <a:solidFill>
-              <a:srgbClr val="3ECF8E"/>
-            </a:solidFill>
-            <a:prstDash val="solid"/>
-          </a:ln>
-        </p:spPr>
-      </p:sp>
-      <p:sp>
-        <p:nvSpPr>
-          <p:cNvPr id="5" name="Text 3"/>
-          <p:cNvSpPr/>
-          <p:nvPr/>
-        </p:nvSpPr>
-        <p:spPr>
-          <a:xfrm>
-            <a:off x="640080" y="1143000"/>
-            <a:ext cx="3657600" cy="292608"/>
+          <p:cNvPr id="4" name="Text 2"/>
+          <p:cNvSpPr/>
+          <p:nvPr/>
+        </p:nvSpPr>
+        <p:spPr>
+          <a:xfrm>
+            <a:off x="457200" y="868680"/>
+            <a:ext cx="8229600" cy="320040"/>
           </a:xfrm>
           <a:prstGeom prst="rect">
             <a:avLst/>
@@ -5415,7 +5388,7 @@
                   <a:srgbClr val="3ECF8E"/>
                 </a:solidFill>
               </a:rPr>
-              <a:t>Goal achieved?</a:t>
+              <a:t>Yes — for the defined academic MVP (not production readiness).</a:t>
             </a:r>
             <a:endParaRPr lang="en-US" sz="1500" dirty="0"/>
           </a:p>
@@ -5423,14 +5396,14 @@
       </p:sp>
       <p:sp>
         <p:nvSpPr>
-          <p:cNvPr id="6" name="Text 4"/>
-          <p:cNvSpPr/>
-          <p:nvPr/>
-        </p:nvSpPr>
-        <p:spPr>
-          <a:xfrm>
-            <a:off x="640080" y="1554480"/>
-            <a:ext cx="3657600" cy="2377440"/>
+          <p:cNvPr id="5" name="Text 3"/>
+          <p:cNvSpPr/>
+          <p:nvPr/>
+        </p:nvSpPr>
+        <p:spPr>
+          <a:xfrm>
+            <a:off x="457200" y="1280160"/>
+            <a:ext cx="4114800" cy="256032"/>
           </a:xfrm>
           <a:prstGeom prst="rect">
             <a:avLst/>
@@ -5439,19 +5412,19 @@
           <a:ln/>
         </p:spPr>
         <p:txBody>
-          <a:bodyPr wrap="square" lIns="0" tIns="0" rIns="0" bIns="0" rtlCol="0" anchor="t"/>
+          <a:bodyPr wrap="square" lIns="0" tIns="0" rIns="0" bIns="0" rtlCol="0" anchor="ctr"/>
           <a:lstStyle/>
           <a:p>
             <a:pPr indent="0" marL="0">
               <a:buNone/>
             </a:pPr>
             <a:r>
-              <a:rPr lang="en-US" sz="1300" dirty="0">
-                <a:solidFill>
-                  <a:srgbClr val="E8EEF7"/>
-                </a:solidFill>
-              </a:rPr>
-              <a:t>Yes — for the defined academic objective: a reliable local full-stack demonstration of Task 2 requirements (SPA, backend, tests, Docker, documentation), not a commercial product.</a:t>
+              <a:rPr lang="en-US" sz="1300" b="1" dirty="0">
+                <a:solidFill>
+                  <a:srgbClr val="4F8CFF"/>
+                </a:solidFill>
+              </a:rPr>
+              <a:t>Evidence</a:t>
             </a:r>
             <a:endParaRPr lang="en-US" sz="1300" dirty="0"/>
           </a:p>
@@ -5459,41 +5432,14 @@
       </p:sp>
       <p:sp>
         <p:nvSpPr>
-          <p:cNvPr id="7" name="Shape 5"/>
-          <p:cNvSpPr/>
-          <p:nvPr/>
-        </p:nvSpPr>
-        <p:spPr>
-          <a:xfrm>
-            <a:off x="4663440" y="1005840"/>
-            <a:ext cx="4023360" cy="3200400"/>
-          </a:xfrm>
-          <a:prstGeom prst="roundRect">
-            <a:avLst>
-              <a:gd name="adj" fmla="val 2286"/>
-            </a:avLst>
-          </a:prstGeom>
-          <a:solidFill>
-            <a:srgbClr val="1A2332"/>
-          </a:solidFill>
-          <a:ln w="12700">
-            <a:solidFill>
-              <a:srgbClr val="334155"/>
-            </a:solidFill>
-            <a:prstDash val="solid"/>
-          </a:ln>
-        </p:spPr>
-      </p:sp>
-      <p:sp>
-        <p:nvSpPr>
-          <p:cNvPr id="8" name="Text 6"/>
-          <p:cNvSpPr/>
-          <p:nvPr/>
-        </p:nvSpPr>
-        <p:spPr>
-          <a:xfrm>
-            <a:off x="4846320" y="1143000"/>
-            <a:ext cx="3657600" cy="292608"/>
+          <p:cNvPr id="6" name="Text 4"/>
+          <p:cNvSpPr/>
+          <p:nvPr/>
+        </p:nvSpPr>
+        <p:spPr>
+          <a:xfrm>
+            <a:off x="457200" y="1554480"/>
+            <a:ext cx="4114800" cy="2834640"/>
           </a:xfrm>
           <a:prstGeom prst="rect">
             <a:avLst/>
@@ -5502,34 +5448,164 @@
           <a:ln/>
         </p:spPr>
         <p:txBody>
-          <a:bodyPr wrap="square" lIns="0" tIns="0" rIns="0" bIns="0" rtlCol="0" anchor="ctr"/>
-          <a:lstStyle/>
-          <a:p>
-            <a:pPr indent="0" marL="0">
-              <a:buNone/>
-            </a:pPr>
-            <a:r>
-              <a:rPr lang="en-US" sz="1500" b="1" dirty="0">
-                <a:solidFill>
-                  <a:srgbClr val="9AABBF"/>
-                </a:solidFill>
-              </a:rPr>
-              <a:t>Known limitations (by design)</a:t>
-            </a:r>
-            <a:endParaRPr lang="en-US" sz="1500" dirty="0"/>
-          </a:p>
-        </p:txBody>
-      </p:sp>
-      <p:sp>
-        <p:nvSpPr>
-          <p:cNvPr id="9" name="Text 7"/>
-          <p:cNvSpPr/>
-          <p:nvPr/>
-        </p:nvSpPr>
-        <p:spPr>
-          <a:xfrm>
-            <a:off x="4846320" y="1554480"/>
-            <a:ext cx="3657600" cy="2377440"/>
+          <a:bodyPr wrap="square" rtlCol="0" anchor="ctr"/>
+          <a:lstStyle/>
+          <a:p>
+            <a:pPr marL="342900" indent="-342900">
+              <a:spcAft>
+                <a:spcPts val="300"/>
+              </a:spcAft>
+              <a:buSzPct val="100000"/>
+              <a:buChar char="•"/>
+            </a:pPr>
+            <a:r>
+              <a:rPr lang="en-US" sz="1200" dirty="0">
+                <a:solidFill>
+                  <a:srgbClr val="E8EEF7"/>
+                </a:solidFill>
+              </a:rPr>
+              <a:t>Two anonymous browser sessions</a:t>
+            </a:r>
+            <a:endParaRPr lang="en-US" sz="1200" dirty="0"/>
+          </a:p>
+          <a:p>
+            <a:pPr marL="342900" indent="-342900">
+              <a:spcAft>
+                <a:spcPts val="300"/>
+              </a:spcAft>
+              <a:buSzPct val="100000"/>
+              <a:buChar char="•"/>
+            </a:pPr>
+            <a:r>
+              <a:rPr lang="en-US" sz="1200" dirty="0">
+                <a:solidFill>
+                  <a:srgbClr val="E8EEF7"/>
+                </a:solidFill>
+              </a:rPr>
+              <a:t>Interest matchmaking (3→2→1)</a:t>
+            </a:r>
+            <a:endParaRPr lang="en-US" sz="1200" dirty="0"/>
+          </a:p>
+          <a:p>
+            <a:pPr marL="342900" indent="-342900">
+              <a:spcAft>
+                <a:spcPts val="300"/>
+              </a:spcAft>
+              <a:buSzPct val="100000"/>
+              <a:buChar char="•"/>
+            </a:pPr>
+            <a:r>
+              <a:rPr lang="en-US" sz="1200" dirty="0">
+                <a:solidFill>
+                  <a:srgbClr val="E8EEF7"/>
+                </a:solidFill>
+              </a:rPr>
+              <a:t>10-question completion + scoring</a:t>
+            </a:r>
+            <a:endParaRPr lang="en-US" sz="1200" dirty="0"/>
+          </a:p>
+          <a:p>
+            <a:pPr marL="342900" indent="-342900">
+              <a:spcAft>
+                <a:spcPts val="300"/>
+              </a:spcAft>
+              <a:buSzPct val="100000"/>
+              <a:buChar char="•"/>
+            </a:pPr>
+            <a:r>
+              <a:rPr lang="en-US" sz="1200" dirty="0">
+                <a:solidFill>
+                  <a:srgbClr val="E8EEF7"/>
+                </a:solidFill>
+              </a:rPr>
+              <a:t>Flags → THREE_FLAGS termination</a:t>
+            </a:r>
+            <a:endParaRPr lang="en-US" sz="1200" dirty="0"/>
+          </a:p>
+          <a:p>
+            <a:pPr marL="342900" indent="-342900">
+              <a:spcAft>
+                <a:spcPts val="300"/>
+              </a:spcAft>
+              <a:buSzPct val="100000"/>
+              <a:buChar char="•"/>
+            </a:pPr>
+            <a:r>
+              <a:rPr lang="en-US" sz="1200" dirty="0">
+                <a:solidFill>
+                  <a:srgbClr val="E8EEF7"/>
+                </a:solidFill>
+              </a:rPr>
+              <a:t>Results exclude flagged scores</a:t>
+            </a:r>
+            <a:endParaRPr lang="en-US" sz="1200" dirty="0"/>
+          </a:p>
+          <a:p>
+            <a:pPr marL="342900" indent="-342900">
+              <a:spcAft>
+                <a:spcPts val="300"/>
+              </a:spcAft>
+              <a:buSzPct val="100000"/>
+              <a:buChar char="•"/>
+            </a:pPr>
+            <a:r>
+              <a:rPr lang="en-US" sz="1200" dirty="0">
+                <a:solidFill>
+                  <a:srgbClr val="E8EEF7"/>
+                </a:solidFill>
+              </a:rPr>
+              <a:t>SPA + API + Postgres integrate</a:t>
+            </a:r>
+            <a:endParaRPr lang="en-US" sz="1200" dirty="0"/>
+          </a:p>
+          <a:p>
+            <a:pPr marL="342900" indent="-342900">
+              <a:spcAft>
+                <a:spcPts val="300"/>
+              </a:spcAft>
+              <a:buSzPct val="100000"/>
+              <a:buChar char="•"/>
+            </a:pPr>
+            <a:r>
+              <a:rPr lang="en-US" sz="1200" dirty="0">
+                <a:solidFill>
+                  <a:srgbClr val="E8EEF7"/>
+                </a:solidFill>
+              </a:rPr>
+              <a:t>Docker Compose one-command run</a:t>
+            </a:r>
+            <a:endParaRPr lang="en-US" sz="1200" dirty="0"/>
+          </a:p>
+          <a:p>
+            <a:pPr marL="342900" indent="-342900">
+              <a:spcAft>
+                <a:spcPts val="300"/>
+              </a:spcAft>
+              <a:buSzPct val="100000"/>
+              <a:buChar char="•"/>
+            </a:pPr>
+            <a:r>
+              <a:rPr lang="en-US" sz="1200" dirty="0">
+                <a:solidFill>
+                  <a:srgbClr val="E8EEF7"/>
+                </a:solidFill>
+              </a:rPr>
+              <a:t>Automated tests pass (FE + BE)</a:t>
+            </a:r>
+            <a:endParaRPr lang="en-US" sz="1200" dirty="0"/>
+          </a:p>
+        </p:txBody>
+      </p:sp>
+      <p:sp>
+        <p:nvSpPr>
+          <p:cNvPr id="7" name="Text 5"/>
+          <p:cNvSpPr/>
+          <p:nvPr/>
+        </p:nvSpPr>
+        <p:spPr>
+          <a:xfrm>
+            <a:off x="4846320" y="1280160"/>
+            <a:ext cx="3840480" cy="256032"/>
           </a:xfrm>
           <a:prstGeom prst="rect">
             <a:avLst/>
@@ -5538,6 +5614,42 @@
           <a:ln/>
         </p:spPr>
         <p:txBody>
+          <a:bodyPr wrap="square" lIns="0" tIns="0" rIns="0" bIns="0" rtlCol="0" anchor="ctr"/>
+          <a:lstStyle/>
+          <a:p>
+            <a:pPr indent="0" marL="0">
+              <a:buNone/>
+            </a:pPr>
+            <a:r>
+              <a:rPr lang="en-US" sz="1300" b="1" dirty="0">
+                <a:solidFill>
+                  <a:srgbClr val="9AABBF"/>
+                </a:solidFill>
+              </a:rPr>
+              <a:t>Limitations (intentional)</a:t>
+            </a:r>
+            <a:endParaRPr lang="en-US" sz="1300" dirty="0"/>
+          </a:p>
+        </p:txBody>
+      </p:sp>
+      <p:sp>
+        <p:nvSpPr>
+          <p:cNvPr id="8" name="Text 6"/>
+          <p:cNvSpPr/>
+          <p:nvPr/>
+        </p:nvSpPr>
+        <p:spPr>
+          <a:xfrm>
+            <a:off x="4846320" y="1645920"/>
+            <a:ext cx="3840480" cy="2651760"/>
+          </a:xfrm>
+          <a:prstGeom prst="rect">
+            <a:avLst/>
+          </a:prstGeom>
+          <a:noFill/>
+          <a:ln/>
+        </p:spPr>
+        <p:txBody>
           <a:bodyPr wrap="square" lIns="0" tIns="0" rIns="0" bIns="0" rtlCol="0" anchor="t"/>
           <a:lstStyle/>
           <a:p>
@@ -5545,20 +5657,20 @@
               <a:buNone/>
             </a:pPr>
             <a:r>
-              <a:rPr lang="en-US" sz="1300" dirty="0">
+              <a:rPr lang="en-US" sz="1200" dirty="0">
                 <a:solidFill>
                   <a:srgbClr val="E8EEF7"/>
                 </a:solidFill>
               </a:rPr>
-              <a:t>No accounts · no production auth · polling not WebSockets · no disconnect recovery · subjective scoring · no moderation/history/audio · local Docker only · no production scale strategy.</a:t>
-            </a:r>
-            <a:endParaRPr lang="en-US" sz="1300" dirty="0"/>
-          </a:p>
-        </p:txBody>
-      </p:sp>
-      <p:sp>
-        <p:nvSpPr>
-          <p:cNvPr id="10" name="Text 8"/>
+              <a:t>Excluded to protect scope and demo reliability: no accounts/production auth, polling not WebSockets, no disconnect recovery, subjective scoring, no moderation/history/audio, local Docker only, no production scale. Design choices — not unfinished MVP work.</a:t>
+            </a:r>
+            <a:endParaRPr lang="en-US" sz="1200" dirty="0"/>
+          </a:p>
+        </p:txBody>
+      </p:sp>
+      <p:sp>
+        <p:nvSpPr>
+          <p:cNvPr id="9" name="Text 7"/>
           <p:cNvSpPr/>
           <p:nvPr/>
         </p:nvSpPr>
@@ -5597,7 +5709,7 @@
       </p:sp>
       <p:sp>
         <p:nvSpPr>
-          <p:cNvPr id="11" name="Text 9"/>
+          <p:cNvPr id="10" name="Text 8"/>
           <p:cNvSpPr/>
           <p:nvPr/>
         </p:nvSpPr>

</xml_diff>